<commit_message>
chore(presentation): slide 9 plné znění otázek z posudků, layout pod sebou, datum obhajoby
</commit_message>
<xml_diff>
--- a/presentation/work/obhajoba-draft-v1.pptx
+++ b/presentation/work/obhajoba-draft-v1.pptx
@@ -12821,8 +12821,8 @@
         </p:nvSpPr>
         <p:spPr>
           <a:xfrm>
-            <a:off x="629107" y="1097280"/>
-            <a:ext cx="7779715" cy="548640"/>
+            <a:off x="411480" y="182880"/>
+            <a:ext cx="7818120" cy="457200"/>
           </a:xfrm>
           <a:prstGeom prst="rect">
             <a:avLst/>
@@ -12840,7 +12840,7 @@
           <a:p>
             <a:pPr algn="ctr"/>
             <a:r>
-              <a:rPr sz="3600" b="1" i="0">
+              <a:rPr sz="2800" b="1" i="0">
                 <a:solidFill>
                   <a:srgbClr val="009881"/>
                 </a:solidFill>
@@ -12858,8 +12858,8 @@
         </p:nvSpPr>
         <p:spPr>
           <a:xfrm>
-            <a:off x="629107" y="1828800"/>
-            <a:ext cx="3611880" cy="320040"/>
+            <a:off x="411480" y="713232"/>
+            <a:ext cx="7818120" cy="256032"/>
           </a:xfrm>
           <a:prstGeom prst="rect">
             <a:avLst/>
@@ -12875,14 +12875,14 @@
           </a:bodyPr>
           <a:lstStyle/>
           <a:p>
-            <a:pPr algn="l"/>
-            <a:r>
-              <a:rPr sz="1600" b="1" i="0">
-                <a:solidFill>
-                  <a:srgbClr val="009881"/>
+            <a:pPr algn="ctr"/>
+            <a:r>
+              <a:rPr sz="1000" b="0" i="1">
+                <a:solidFill>
+                  <a:srgbClr val="4A4A49"/>
                 </a:solidFill>
               </a:rPr>
-              <a:t>Otázky vedoucího</a:t>
+              <a:t>Vedoucí: Ing. Jiří Korčák     ·     Oponent: Ing. Richard Antonín Novák, Ph.D.     ·     Obhajoba: 15. – 26. 6. 2026 (přesný den dle rozpisu SZZ, InSIS)</a:t>
             </a:r>
           </a:p>
         </p:txBody>
@@ -12895,8 +12895,8 @@
         </p:nvSpPr>
         <p:spPr>
           <a:xfrm>
-            <a:off x="629107" y="2148840"/>
-            <a:ext cx="3611880" cy="228600"/>
+            <a:off x="411480" y="1097280"/>
+            <a:ext cx="7818120" cy="274320"/>
           </a:xfrm>
           <a:prstGeom prst="rect">
             <a:avLst/>
@@ -12914,12 +12914,12 @@
           <a:p>
             <a:pPr algn="l"/>
             <a:r>
-              <a:rPr sz="1100" b="0" i="1">
-                <a:solidFill>
-                  <a:srgbClr val="4A4A49"/>
+              <a:rPr sz="1400" b="1" i="0">
+                <a:solidFill>
+                  <a:srgbClr val="009881"/>
                 </a:solidFill>
               </a:rPr>
-              <a:t>Ing. Jiří Korčák</a:t>
+              <a:t>Vedoucí — Ing. Jiří Korčák (4 otázky)</a:t>
             </a:r>
           </a:p>
         </p:txBody>
@@ -12932,8 +12932,8 @@
         </p:nvSpPr>
         <p:spPr>
           <a:xfrm>
-            <a:off x="629107" y="2377440"/>
-            <a:ext cx="3611880" cy="594360"/>
+            <a:off x="411480" y="1389888"/>
+            <a:ext cx="7818120" cy="713232"/>
           </a:xfrm>
           <a:prstGeom prst="rect">
             <a:avLst/>
@@ -12951,12 +12951,12 @@
           <a:p>
             <a:pPr algn="l"/>
             <a:r>
-              <a:rPr sz="1300" b="0" i="0">
+              <a:rPr sz="1000" b="0" i="0">
                 <a:solidFill>
                   <a:srgbClr val="4A4A49"/>
                 </a:solidFill>
               </a:rPr>
-              <a:t>1. Role ablační studie — proč nestačily pilotní iterace?</a:t>
+              <a:t>1) Vysvětlete vlastními slovy, jakou roli ve Vaší práci hraje ablační studie a proč nestačilo pouze porovnat jednotlivé pilotní běhy agenta.</a:t>
             </a:r>
           </a:p>
         </p:txBody>
@@ -12969,8 +12969,8 @@
         </p:nvSpPr>
         <p:spPr>
           <a:xfrm>
-            <a:off x="629107" y="2971800"/>
-            <a:ext cx="3611880" cy="594360"/>
+            <a:off x="411480" y="2103120"/>
+            <a:ext cx="7818120" cy="713232"/>
           </a:xfrm>
           <a:prstGeom prst="rect">
             <a:avLst/>
@@ -12988,12 +12988,12 @@
           <a:p>
             <a:pPr algn="l"/>
             <a:r>
-              <a:rPr sz="1300" b="0" i="0">
+              <a:rPr sz="1000" b="0" i="0">
                 <a:solidFill>
                   <a:srgbClr val="4A4A49"/>
                 </a:solidFill>
               </a:rPr>
-              <a:t>2. Rozdíl procesních, produktových a zdrojových metrik — konkrétní příklad?</a:t>
+              <a:t>2) Jaký je rozdíl mezi procesními, produktovými a zdrojovými metrikami ve Vašem návrhu? Uveďte konkrétní příklad metriky z každé skupiny a vysvětlete, proč je důležitá, jakou má oporu ve zdrojích a jak je v práci prakticky měřená.</a:t>
             </a:r>
           </a:p>
         </p:txBody>
@@ -13006,8 +13006,8 @@
         </p:nvSpPr>
         <p:spPr>
           <a:xfrm>
-            <a:off x="629107" y="3566160"/>
-            <a:ext cx="3611880" cy="594360"/>
+            <a:off x="411480" y="2816352"/>
+            <a:ext cx="7818120" cy="713232"/>
           </a:xfrm>
           <a:prstGeom prst="rect">
             <a:avLst/>
@@ -13025,12 +13025,12 @@
           <a:p>
             <a:pPr algn="l"/>
             <a:r>
-              <a:rPr sz="1300" b="0" i="0">
+              <a:rPr sz="1000" b="0" i="0">
                 <a:solidFill>
                   <a:srgbClr val="4A4A49"/>
                 </a:solidFill>
               </a:rPr>
-              <a:t>3. Jak odlišit vlastní přínos od přínosu AI asistenta?</a:t>
+              <a:t>3) Jak jste rozlišoval mezi vlastním autorským přínosem a výstupy AI asistenta při tvorbě textu, diagnostiky experimentu a měřicí infrastruktury?</a:t>
             </a:r>
           </a:p>
         </p:txBody>
@@ -13043,8 +13043,8 @@
         </p:nvSpPr>
         <p:spPr>
           <a:xfrm>
-            <a:off x="629107" y="4160520"/>
-            <a:ext cx="3611880" cy="594360"/>
+            <a:off x="411480" y="3529584"/>
+            <a:ext cx="7818120" cy="713232"/>
           </a:xfrm>
           <a:prstGeom prst="rect">
             <a:avLst/>
@@ -13062,12 +13062,12 @@
           <a:p>
             <a:pPr algn="l"/>
             <a:r>
-              <a:rPr sz="1300" b="0" i="0">
+              <a:rPr sz="1000" b="0" i="0">
                 <a:solidFill>
                   <a:srgbClr val="4A4A49"/>
                 </a:solidFill>
               </a:rPr>
-              <a:t>4. Pravidlo → příkaz → verifikační krok — konkrétní příklad?</a:t>
+              <a:t>4) V práci zmiňujete posun od obecného pravidla ke konkrétnímu příkazu a následně k verifikačnímu kroku. Uveďte konkrétní příklad z Vaší případové studie a vysvětlete, proč právě verifikační krok zlepšil chování agenta.</a:t>
             </a:r>
           </a:p>
         </p:txBody>
@@ -13080,8 +13080,8 @@
         </p:nvSpPr>
         <p:spPr>
           <a:xfrm>
-            <a:off x="4754880" y="1828800"/>
-            <a:ext cx="3611880" cy="320040"/>
+            <a:off x="411480" y="4334256"/>
+            <a:ext cx="7818120" cy="274320"/>
           </a:xfrm>
           <a:prstGeom prst="rect">
             <a:avLst/>
@@ -13099,12 +13099,12 @@
           <a:p>
             <a:pPr algn="l"/>
             <a:r>
-              <a:rPr sz="1600" b="1" i="0">
+              <a:rPr sz="1400" b="1" i="0">
                 <a:solidFill>
                   <a:srgbClr val="009881"/>
                 </a:solidFill>
               </a:rPr>
-              <a:t>Otázky oponenta</a:t>
+              <a:t>Oponent — Ing. Richard Antonín Novák, Ph.D. (1 otázka)</a:t>
             </a:r>
           </a:p>
         </p:txBody>
@@ -13117,8 +13117,8 @@
         </p:nvSpPr>
         <p:spPr>
           <a:xfrm>
-            <a:off x="4754880" y="2148840"/>
-            <a:ext cx="3611880" cy="228600"/>
+            <a:off x="411480" y="4626864"/>
+            <a:ext cx="7818120" cy="1005840"/>
           </a:xfrm>
           <a:prstGeom prst="rect">
             <a:avLst/>
@@ -13136,49 +13136,12 @@
           <a:p>
             <a:pPr algn="l"/>
             <a:r>
-              <a:rPr sz="1100" b="0" i="1">
+              <a:rPr sz="1000" b="0" i="0">
                 <a:solidFill>
                   <a:srgbClr val="4A4A49"/>
                 </a:solidFill>
               </a:rPr>
-              <a:t>Ing. Richard Antonín Novák, Ph.D.</a:t>
-            </a:r>
-          </a:p>
-        </p:txBody>
-      </p:sp>
-      <p:sp>
-        <p:nvSpPr>
-          <p:cNvPr id="11" name="TextBox 10"/>
-          <p:cNvSpPr txBox="1"/>
-          <p:nvPr/>
-        </p:nvSpPr>
-        <p:spPr>
-          <a:xfrm>
-            <a:off x="4754880" y="2377440"/>
-            <a:ext cx="3611880" cy="594360"/>
-          </a:xfrm>
-          <a:prstGeom prst="rect">
-            <a:avLst/>
-          </a:prstGeom>
-          <a:noFill/>
-          <a:ln>
-            <a:noFill/>
-          </a:ln>
-        </p:spPr>
-        <p:txBody>
-          <a:bodyPr wrap="square" lIns="73152" rIns="73152" tIns="36576" bIns="36576">
-            <a:spAutoFit/>
-          </a:bodyPr>
-          <a:lstStyle/>
-          <a:p>
-            <a:pPr algn="l"/>
-            <a:r>
-              <a:rPr sz="1300" b="0" i="0">
-                <a:solidFill>
-                  <a:srgbClr val="4A4A49"/>
-                </a:solidFill>
-              </a:rPr>
-              <a:t>1. Termín "Ablace" — hlubší vysvětlení pojmu a jeho role v práci?</a:t>
+              <a:t>1) V práci hodně používáte termín Ablace a Ablační studie, vysvětlete více do hloubky jakou tento termín hraje roli při vašem testování kvality SW při zapojení AI coding agenta?</a:t>
             </a:r>
           </a:p>
         </p:txBody>

</xml_diff>

<commit_message>
chore(presentation): slide 9 - sjednotit styly s ostatními slidy a ponechat jen datum obhajoby
</commit_message>
<xml_diff>
--- a/presentation/work/obhajoba-draft-v1.pptx
+++ b/presentation/work/obhajoba-draft-v1.pptx
@@ -12821,8 +12821,8 @@
         </p:nvSpPr>
         <p:spPr>
           <a:xfrm>
-            <a:off x="411480" y="182880"/>
-            <a:ext cx="7818120" cy="457200"/>
+            <a:off x="502920" y="228600"/>
+            <a:ext cx="7680960" cy="548640"/>
           </a:xfrm>
           <a:prstGeom prst="rect">
             <a:avLst/>
@@ -12838,14 +12838,14 @@
           </a:bodyPr>
           <a:lstStyle/>
           <a:p>
-            <a:pPr algn="ctr"/>
-            <a:r>
-              <a:rPr sz="2800" b="1" i="0">
+            <a:pPr algn="l"/>
+            <a:r>
+              <a:rPr sz="2600" b="1" i="0">
                 <a:solidFill>
                   <a:srgbClr val="009881"/>
                 </a:solidFill>
               </a:rPr>
-              <a:t>Otázky</a:t>
+              <a:t>Otázky z posudků</a:t>
             </a:r>
           </a:p>
         </p:txBody>
@@ -12858,8 +12858,8 @@
         </p:nvSpPr>
         <p:spPr>
           <a:xfrm>
-            <a:off x="411480" y="713232"/>
-            <a:ext cx="7818120" cy="256032"/>
+            <a:off x="502920" y="841248"/>
+            <a:ext cx="7680960" cy="292608"/>
           </a:xfrm>
           <a:prstGeom prst="rect">
             <a:avLst/>
@@ -12875,14 +12875,14 @@
           </a:bodyPr>
           <a:lstStyle/>
           <a:p>
-            <a:pPr algn="ctr"/>
-            <a:r>
-              <a:rPr sz="1000" b="0" i="1">
+            <a:pPr algn="l"/>
+            <a:r>
+              <a:rPr sz="1100" b="0" i="1">
                 <a:solidFill>
                   <a:srgbClr val="4A4A49"/>
                 </a:solidFill>
               </a:rPr>
-              <a:t>Vedoucí: Ing. Jiří Korčák     ·     Oponent: Ing. Richard Antonín Novák, Ph.D.     ·     Obhajoba: 23. 6. 2026, 12:45</a:t>
+              <a:t>Vedoucí: Ing. Jiří Korčák    ·    Oponent: Ing. Richard Antonín Novák, Ph.D.    ·    Obhajoba: 23. 6. 2026</a:t>
             </a:r>
           </a:p>
         </p:txBody>
@@ -12895,8 +12895,8 @@
         </p:nvSpPr>
         <p:spPr>
           <a:xfrm>
-            <a:off x="411480" y="1097280"/>
-            <a:ext cx="7818120" cy="274320"/>
+            <a:off x="502920" y="1325880"/>
+            <a:ext cx="7680960" cy="292608"/>
           </a:xfrm>
           <a:prstGeom prst="rect">
             <a:avLst/>
@@ -12919,7 +12919,7 @@
                   <a:srgbClr val="009881"/>
                 </a:solidFill>
               </a:rPr>
-              <a:t>Vedoucí — Ing. Jiří Korčák (4 otázky)</a:t>
+              <a:t>Vedoucí — Ing. Jiří Korčák    ·    4 otázky</a:t>
             </a:r>
           </a:p>
         </p:txBody>
@@ -12932,8 +12932,8 @@
         </p:nvSpPr>
         <p:spPr>
           <a:xfrm>
-            <a:off x="411480" y="1389888"/>
-            <a:ext cx="7818120" cy="713232"/>
+            <a:off x="502920" y="1673352"/>
+            <a:ext cx="320040" cy="713232"/>
           </a:xfrm>
           <a:prstGeom prst="rect">
             <a:avLst/>
@@ -12951,12 +12951,12 @@
           <a:p>
             <a:pPr algn="l"/>
             <a:r>
-              <a:rPr sz="1000" b="0" i="0">
-                <a:solidFill>
-                  <a:srgbClr val="4A4A49"/>
+              <a:rPr sz="1200" b="1" i="0">
+                <a:solidFill>
+                  <a:srgbClr val="009881"/>
                 </a:solidFill>
               </a:rPr>
-              <a:t>1) Vysvětlete vlastními slovy, jakou roli ve Vaší práci hraje ablační studie a proč nestačilo pouze porovnat jednotlivé pilotní běhy agenta.</a:t>
+              <a:t>1.</a:t>
             </a:r>
           </a:p>
         </p:txBody>
@@ -12969,8 +12969,8 @@
         </p:nvSpPr>
         <p:spPr>
           <a:xfrm>
-            <a:off x="411480" y="2103120"/>
-            <a:ext cx="7818120" cy="713232"/>
+            <a:off x="822960" y="1673352"/>
+            <a:ext cx="7360920" cy="713232"/>
           </a:xfrm>
           <a:prstGeom prst="rect">
             <a:avLst/>
@@ -12988,12 +12988,12 @@
           <a:p>
             <a:pPr algn="l"/>
             <a:r>
-              <a:rPr sz="1000" b="0" i="0">
+              <a:rPr sz="1100" b="0" i="0">
                 <a:solidFill>
                   <a:srgbClr val="4A4A49"/>
                 </a:solidFill>
               </a:rPr>
-              <a:t>2) Jaký je rozdíl mezi procesními, produktovými a zdrojovými metrikami ve Vašem návrhu? Uveďte konkrétní příklad metriky z každé skupiny a vysvětlete, proč je důležitá, jakou má oporu ve zdrojích a jak je v práci prakticky měřená.</a:t>
+              <a:t>Vysvětlete vlastními slovy, jakou roli ve Vaší práci hraje ablační studie a proč nestačilo pouze porovnat jednotlivé pilotní běhy agenta.</a:t>
             </a:r>
           </a:p>
         </p:txBody>
@@ -13006,8 +13006,8 @@
         </p:nvSpPr>
         <p:spPr>
           <a:xfrm>
-            <a:off x="411480" y="2816352"/>
-            <a:ext cx="7818120" cy="713232"/>
+            <a:off x="502920" y="2386584"/>
+            <a:ext cx="320040" cy="713232"/>
           </a:xfrm>
           <a:prstGeom prst="rect">
             <a:avLst/>
@@ -13025,12 +13025,12 @@
           <a:p>
             <a:pPr algn="l"/>
             <a:r>
-              <a:rPr sz="1000" b="0" i="0">
-                <a:solidFill>
-                  <a:srgbClr val="4A4A49"/>
+              <a:rPr sz="1200" b="1" i="0">
+                <a:solidFill>
+                  <a:srgbClr val="009881"/>
                 </a:solidFill>
               </a:rPr>
-              <a:t>3) Jak jste rozlišoval mezi vlastním autorským přínosem a výstupy AI asistenta při tvorbě textu, diagnostiky experimentu a měřicí infrastruktury?</a:t>
+              <a:t>2.</a:t>
             </a:r>
           </a:p>
         </p:txBody>
@@ -13043,8 +13043,8 @@
         </p:nvSpPr>
         <p:spPr>
           <a:xfrm>
-            <a:off x="411480" y="3529584"/>
-            <a:ext cx="7818120" cy="713232"/>
+            <a:off x="822960" y="2386584"/>
+            <a:ext cx="7360920" cy="713232"/>
           </a:xfrm>
           <a:prstGeom prst="rect">
             <a:avLst/>
@@ -13062,12 +13062,12 @@
           <a:p>
             <a:pPr algn="l"/>
             <a:r>
-              <a:rPr sz="1000" b="0" i="0">
+              <a:rPr sz="1100" b="0" i="0">
                 <a:solidFill>
                   <a:srgbClr val="4A4A49"/>
                 </a:solidFill>
               </a:rPr>
-              <a:t>4) V práci zmiňujete posun od obecného pravidla ke konkrétnímu příkazu a následně k verifikačnímu kroku. Uveďte konkrétní příklad z Vaší případové studie a vysvětlete, proč právě verifikační krok zlepšil chování agenta.</a:t>
+              <a:t>Jaký je rozdíl mezi procesními, produktovými a zdrojovými metrikami ve Vašem návrhu? Uveďte konkrétní příklad metriky z každé skupiny a vysvětlete, proč je důležitá, jakou má oporu ve zdrojích a jak je v práci prakticky měřená.</a:t>
             </a:r>
           </a:p>
         </p:txBody>
@@ -13080,8 +13080,8 @@
         </p:nvSpPr>
         <p:spPr>
           <a:xfrm>
-            <a:off x="411480" y="4334256"/>
-            <a:ext cx="7818120" cy="274320"/>
+            <a:off x="502920" y="3099816"/>
+            <a:ext cx="320040" cy="713232"/>
           </a:xfrm>
           <a:prstGeom prst="rect">
             <a:avLst/>
@@ -13099,12 +13099,12 @@
           <a:p>
             <a:pPr algn="l"/>
             <a:r>
-              <a:rPr sz="1400" b="1" i="0">
+              <a:rPr sz="1200" b="1" i="0">
                 <a:solidFill>
                   <a:srgbClr val="009881"/>
                 </a:solidFill>
               </a:rPr>
-              <a:t>Oponent — Ing. Richard Antonín Novák, Ph.D. (1 otázka)</a:t>
+              <a:t>3.</a:t>
             </a:r>
           </a:p>
         </p:txBody>
@@ -13117,8 +13117,8 @@
         </p:nvSpPr>
         <p:spPr>
           <a:xfrm>
-            <a:off x="411480" y="4626864"/>
-            <a:ext cx="7818120" cy="1005840"/>
+            <a:off x="822960" y="3099816"/>
+            <a:ext cx="7360920" cy="713232"/>
           </a:xfrm>
           <a:prstGeom prst="rect">
             <a:avLst/>
@@ -13136,12 +13136,197 @@
           <a:p>
             <a:pPr algn="l"/>
             <a:r>
-              <a:rPr sz="1000" b="0" i="0">
+              <a:rPr sz="1100" b="0" i="0">
                 <a:solidFill>
                   <a:srgbClr val="4A4A49"/>
                 </a:solidFill>
               </a:rPr>
-              <a:t>1) V práci hodně používáte termín Ablace a Ablační studie, vysvětlete více do hloubky jakou tento termín hraje roli při vašem testování kvality SW při zapojení AI coding agenta?</a:t>
+              <a:t>Jak jste rozlišoval mezi vlastním autorským přínosem a výstupy AI asistenta při tvorbě textu, diagnostiky experimentu a měřicí infrastruktury?</a:t>
+            </a:r>
+          </a:p>
+        </p:txBody>
+      </p:sp>
+      <p:sp>
+        <p:nvSpPr>
+          <p:cNvPr id="11" name="TextBox 10"/>
+          <p:cNvSpPr txBox="1"/>
+          <p:nvPr/>
+        </p:nvSpPr>
+        <p:spPr>
+          <a:xfrm>
+            <a:off x="502920" y="3813048"/>
+            <a:ext cx="320040" cy="713232"/>
+          </a:xfrm>
+          <a:prstGeom prst="rect">
+            <a:avLst/>
+          </a:prstGeom>
+          <a:noFill/>
+          <a:ln>
+            <a:noFill/>
+          </a:ln>
+        </p:spPr>
+        <p:txBody>
+          <a:bodyPr wrap="square" lIns="73152" rIns="73152" tIns="36576" bIns="36576">
+            <a:spAutoFit/>
+          </a:bodyPr>
+          <a:lstStyle/>
+          <a:p>
+            <a:pPr algn="l"/>
+            <a:r>
+              <a:rPr sz="1200" b="1" i="0">
+                <a:solidFill>
+                  <a:srgbClr val="009881"/>
+                </a:solidFill>
+              </a:rPr>
+              <a:t>4.</a:t>
+            </a:r>
+          </a:p>
+        </p:txBody>
+      </p:sp>
+      <p:sp>
+        <p:nvSpPr>
+          <p:cNvPr id="12" name="TextBox 11"/>
+          <p:cNvSpPr txBox="1"/>
+          <p:nvPr/>
+        </p:nvSpPr>
+        <p:spPr>
+          <a:xfrm>
+            <a:off x="822960" y="3813048"/>
+            <a:ext cx="7360920" cy="713232"/>
+          </a:xfrm>
+          <a:prstGeom prst="rect">
+            <a:avLst/>
+          </a:prstGeom>
+          <a:noFill/>
+          <a:ln>
+            <a:noFill/>
+          </a:ln>
+        </p:spPr>
+        <p:txBody>
+          <a:bodyPr wrap="square" lIns="73152" rIns="73152" tIns="36576" bIns="36576">
+            <a:spAutoFit/>
+          </a:bodyPr>
+          <a:lstStyle/>
+          <a:p>
+            <a:pPr algn="l"/>
+            <a:r>
+              <a:rPr sz="1100" b="0" i="0">
+                <a:solidFill>
+                  <a:srgbClr val="4A4A49"/>
+                </a:solidFill>
+              </a:rPr>
+              <a:t>V práci zmiňujete posun od obecného pravidla ke konkrétnímu příkazu a následně k verifikačnímu kroku. Uveďte konkrétní příklad z Vaší případové studie a vysvětlete, proč právě verifikační krok zlepšil chování agenta.</a:t>
+            </a:r>
+          </a:p>
+        </p:txBody>
+      </p:sp>
+      <p:sp>
+        <p:nvSpPr>
+          <p:cNvPr id="13" name="TextBox 12"/>
+          <p:cNvSpPr txBox="1"/>
+          <p:nvPr/>
+        </p:nvSpPr>
+        <p:spPr>
+          <a:xfrm>
+            <a:off x="502920" y="4690872"/>
+            <a:ext cx="7680960" cy="292608"/>
+          </a:xfrm>
+          <a:prstGeom prst="rect">
+            <a:avLst/>
+          </a:prstGeom>
+          <a:noFill/>
+          <a:ln>
+            <a:noFill/>
+          </a:ln>
+        </p:spPr>
+        <p:txBody>
+          <a:bodyPr wrap="square" lIns="73152" rIns="73152" tIns="36576" bIns="36576">
+            <a:spAutoFit/>
+          </a:bodyPr>
+          <a:lstStyle/>
+          <a:p>
+            <a:pPr algn="l"/>
+            <a:r>
+              <a:rPr sz="1400" b="1" i="0">
+                <a:solidFill>
+                  <a:srgbClr val="009881"/>
+                </a:solidFill>
+              </a:rPr>
+              <a:t>Oponent — Ing. Richard Antonín Novák, Ph.D.    ·    1 otázka</a:t>
+            </a:r>
+          </a:p>
+        </p:txBody>
+      </p:sp>
+      <p:sp>
+        <p:nvSpPr>
+          <p:cNvPr id="14" name="TextBox 13"/>
+          <p:cNvSpPr txBox="1"/>
+          <p:nvPr/>
+        </p:nvSpPr>
+        <p:spPr>
+          <a:xfrm>
+            <a:off x="502920" y="5038344"/>
+            <a:ext cx="320040" cy="1005840"/>
+          </a:xfrm>
+          <a:prstGeom prst="rect">
+            <a:avLst/>
+          </a:prstGeom>
+          <a:noFill/>
+          <a:ln>
+            <a:noFill/>
+          </a:ln>
+        </p:spPr>
+        <p:txBody>
+          <a:bodyPr wrap="square" lIns="73152" rIns="73152" tIns="36576" bIns="36576">
+            <a:spAutoFit/>
+          </a:bodyPr>
+          <a:lstStyle/>
+          <a:p>
+            <a:pPr algn="l"/>
+            <a:r>
+              <a:rPr sz="1200" b="1" i="0">
+                <a:solidFill>
+                  <a:srgbClr val="009881"/>
+                </a:solidFill>
+              </a:rPr>
+              <a:t>1.</a:t>
+            </a:r>
+          </a:p>
+        </p:txBody>
+      </p:sp>
+      <p:sp>
+        <p:nvSpPr>
+          <p:cNvPr id="15" name="TextBox 14"/>
+          <p:cNvSpPr txBox="1"/>
+          <p:nvPr/>
+        </p:nvSpPr>
+        <p:spPr>
+          <a:xfrm>
+            <a:off x="822960" y="5038344"/>
+            <a:ext cx="7360920" cy="1005840"/>
+          </a:xfrm>
+          <a:prstGeom prst="rect">
+            <a:avLst/>
+          </a:prstGeom>
+          <a:noFill/>
+          <a:ln>
+            <a:noFill/>
+          </a:ln>
+        </p:spPr>
+        <p:txBody>
+          <a:bodyPr wrap="square" lIns="73152" rIns="73152" tIns="36576" bIns="36576">
+            <a:spAutoFit/>
+          </a:bodyPr>
+          <a:lstStyle/>
+          <a:p>
+            <a:pPr algn="l"/>
+            <a:r>
+              <a:rPr sz="1100" b="0" i="0">
+                <a:solidFill>
+                  <a:srgbClr val="4A4A49"/>
+                </a:solidFill>
+              </a:rPr>
+              <a:t>V práci hodně používáte termín Ablace a Ablační studie, vysvětlete více do hloubky jakou tento termín hraje roli při vašem testování kvality SW při zapojení AI coding agenta?</a:t>
             </a:r>
           </a:p>
         </p:txBody>

</xml_diff>

<commit_message>
chore(presentation): slide 9 - nadpis jako placeholder + odstranit duplicitní jména, datum na titulní slide
Slide 9 (Otázky z posudků) ztrácel title placeholder, takže se nadpis
vykresloval jako volný textbox v záhlaví a překrýval logo. Nadpis je teď
klonovaný placeholder ze slide 8 - identická pozice (x=0.69, y=1.20) i styl
jako u ostatních content slidů.

Odstraněn duplicitní metadata řádek (jména vedoucího/oponenta jsou už v
sekčních hlavičkách). Datum obhajoby (23. 6. 2026) přesunuto na titulní
slide. Rozložení otázek přesázeno, aby sedělo nad číslem stránky.

Co-Authored-By: Claude Opus 4.8 <noreply@anthropic.com>
</commit_message>
<xml_diff>
--- a/presentation/work/obhajoba-draft-v1.pptx
+++ b/presentation/work/obhajoba-draft-v1.pptx
@@ -10354,7 +10354,7 @@
           <a:p>
             <a:r>
               <a:rPr lang="cs-CZ" dirty="0"/>
-              <a:t>Datum obhajoby: [TODO červen 2026]</a:t>
+              <a:t>Datum obhajoby: 23. 6. 2026</a:t>
             </a:r>
           </a:p>
         </p:txBody>
@@ -12815,14 +12815,44 @@
       </p:grpSpPr>
       <p:sp>
         <p:nvSpPr>
-          <p:cNvPr id="2" name="TextBox 1"/>
+          <p:cNvPr id="6" name="Nadpis 5">
+            <a:extLst>
+              <a:ext uri="{FF2B5EF4-FFF2-40B4-BE49-F238E27FC236}">
+                <a16:creationId xmlns:a16="http://schemas.microsoft.com/office/drawing/2014/main" id="{FB7216AC-D64E-46AC-BDC6-EF293D050F03}"/>
+              </a:ext>
+            </a:extLst>
+          </p:cNvPr>
+          <p:cNvSpPr>
+            <a:spLocks noGrp="1"/>
+          </p:cNvSpPr>
+          <p:nvPr>
+            <p:ph type="title"/>
+          </p:nvPr>
+        </p:nvSpPr>
+        <p:spPr/>
+        <p:txBody>
+          <a:bodyPr>
+            <a:normAutofit/>
+          </a:bodyPr>
+          <a:lstStyle/>
+          <a:p>
+            <a:r>
+              <a:rPr lang="cs-CZ" dirty="0"/>
+              <a:t>Otázky z posudků</a:t>
+            </a:r>
+          </a:p>
+        </p:txBody>
+      </p:sp>
+      <p:sp>
+        <p:nvSpPr>
+          <p:cNvPr id="7" name="TextBox 6"/>
           <p:cNvSpPr txBox="1"/>
           <p:nvPr/>
         </p:nvSpPr>
         <p:spPr>
           <a:xfrm>
-            <a:off x="502920" y="228600"/>
-            <a:ext cx="7680960" cy="548640"/>
+            <a:off x="629107" y="1874519"/>
+            <a:ext cx="7779715" cy="292608"/>
           </a:xfrm>
           <a:prstGeom prst="rect">
             <a:avLst/>
@@ -12840,26 +12870,26 @@
           <a:p>
             <a:pPr algn="l"/>
             <a:r>
-              <a:rPr sz="2600" b="1" i="0">
+              <a:rPr sz="1400" b="1" i="0">
                 <a:solidFill>
                   <a:srgbClr val="009881"/>
                 </a:solidFill>
               </a:rPr>
-              <a:t>Otázky z posudků</a:t>
-            </a:r>
-          </a:p>
-        </p:txBody>
-      </p:sp>
-      <p:sp>
-        <p:nvSpPr>
-          <p:cNvPr id="3" name="TextBox 2"/>
+              <a:t>Vedoucí — Ing. Jiří Korčák    ·    4 otázky</a:t>
+            </a:r>
+          </a:p>
+        </p:txBody>
+      </p:sp>
+      <p:sp>
+        <p:nvSpPr>
+          <p:cNvPr id="8" name="TextBox 7"/>
           <p:cNvSpPr txBox="1"/>
           <p:nvPr/>
         </p:nvSpPr>
         <p:spPr>
           <a:xfrm>
-            <a:off x="502920" y="841248"/>
-            <a:ext cx="7680960" cy="292608"/>
+            <a:off x="629107" y="2221991"/>
+            <a:ext cx="320040" cy="658368"/>
           </a:xfrm>
           <a:prstGeom prst="rect">
             <a:avLst/>
@@ -12877,26 +12907,26 @@
           <a:p>
             <a:pPr algn="l"/>
             <a:r>
-              <a:rPr sz="1100" b="0" i="1">
-                <a:solidFill>
-                  <a:srgbClr val="4A4A49"/>
+              <a:rPr sz="1200" b="1" i="0">
+                <a:solidFill>
+                  <a:srgbClr val="009881"/>
                 </a:solidFill>
               </a:rPr>
-              <a:t>Vedoucí: Ing. Jiří Korčák    ·    Oponent: Ing. Richard Antonín Novák, Ph.D.    ·    Obhajoba: 23. 6. 2026</a:t>
-            </a:r>
-          </a:p>
-        </p:txBody>
-      </p:sp>
-      <p:sp>
-        <p:nvSpPr>
-          <p:cNvPr id="4" name="TextBox 3"/>
+              <a:t>1.</a:t>
+            </a:r>
+          </a:p>
+        </p:txBody>
+      </p:sp>
+      <p:sp>
+        <p:nvSpPr>
+          <p:cNvPr id="9" name="TextBox 8"/>
           <p:cNvSpPr txBox="1"/>
           <p:nvPr/>
         </p:nvSpPr>
         <p:spPr>
           <a:xfrm>
-            <a:off x="502920" y="1325880"/>
-            <a:ext cx="7680960" cy="292608"/>
+            <a:off x="949147" y="2221991"/>
+            <a:ext cx="7459675" cy="658368"/>
           </a:xfrm>
           <a:prstGeom prst="rect">
             <a:avLst/>
@@ -12914,26 +12944,26 @@
           <a:p>
             <a:pPr algn="l"/>
             <a:r>
-              <a:rPr sz="1400" b="1" i="0">
-                <a:solidFill>
-                  <a:srgbClr val="009881"/>
+              <a:rPr sz="1100" b="0" i="0">
+                <a:solidFill>
+                  <a:srgbClr val="4A4A49"/>
                 </a:solidFill>
               </a:rPr>
-              <a:t>Vedoucí — Ing. Jiří Korčák    ·    4 otázky</a:t>
-            </a:r>
-          </a:p>
-        </p:txBody>
-      </p:sp>
-      <p:sp>
-        <p:nvSpPr>
-          <p:cNvPr id="5" name="TextBox 4"/>
+              <a:t>Vysvětlete vlastními slovy, jakou roli ve Vaší práci hraje ablační studie a proč nestačilo pouze porovnat jednotlivé pilotní běhy agenta.</a:t>
+            </a:r>
+          </a:p>
+        </p:txBody>
+      </p:sp>
+      <p:sp>
+        <p:nvSpPr>
+          <p:cNvPr id="10" name="TextBox 9"/>
           <p:cNvSpPr txBox="1"/>
           <p:nvPr/>
         </p:nvSpPr>
         <p:spPr>
           <a:xfrm>
-            <a:off x="502920" y="1673352"/>
-            <a:ext cx="320040" cy="713232"/>
+            <a:off x="629107" y="2880359"/>
+            <a:ext cx="320040" cy="658368"/>
           </a:xfrm>
           <a:prstGeom prst="rect">
             <a:avLst/>
@@ -12956,21 +12986,21 @@
                   <a:srgbClr val="009881"/>
                 </a:solidFill>
               </a:rPr>
-              <a:t>1.</a:t>
-            </a:r>
-          </a:p>
-        </p:txBody>
-      </p:sp>
-      <p:sp>
-        <p:nvSpPr>
-          <p:cNvPr id="6" name="TextBox 5"/>
+              <a:t>2.</a:t>
+            </a:r>
+          </a:p>
+        </p:txBody>
+      </p:sp>
+      <p:sp>
+        <p:nvSpPr>
+          <p:cNvPr id="11" name="TextBox 10"/>
           <p:cNvSpPr txBox="1"/>
           <p:nvPr/>
         </p:nvSpPr>
         <p:spPr>
           <a:xfrm>
-            <a:off x="822960" y="1673352"/>
-            <a:ext cx="7360920" cy="713232"/>
+            <a:off x="949147" y="2880359"/>
+            <a:ext cx="7459675" cy="658368"/>
           </a:xfrm>
           <a:prstGeom prst="rect">
             <a:avLst/>
@@ -12993,21 +13023,21 @@
                   <a:srgbClr val="4A4A49"/>
                 </a:solidFill>
               </a:rPr>
-              <a:t>Vysvětlete vlastními slovy, jakou roli ve Vaší práci hraje ablační studie a proč nestačilo pouze porovnat jednotlivé pilotní běhy agenta.</a:t>
-            </a:r>
-          </a:p>
-        </p:txBody>
-      </p:sp>
-      <p:sp>
-        <p:nvSpPr>
-          <p:cNvPr id="7" name="TextBox 6"/>
+              <a:t>Jaký je rozdíl mezi procesními, produktovými a zdrojovými metrikami ve Vašem návrhu? Uveďte konkrétní příklad metriky z každé skupiny a vysvětlete, proč je důležitá, jakou má oporu ve zdrojích a jak je v práci prakticky měřená.</a:t>
+            </a:r>
+          </a:p>
+        </p:txBody>
+      </p:sp>
+      <p:sp>
+        <p:nvSpPr>
+          <p:cNvPr id="12" name="TextBox 11"/>
           <p:cNvSpPr txBox="1"/>
           <p:nvPr/>
         </p:nvSpPr>
         <p:spPr>
           <a:xfrm>
-            <a:off x="502920" y="2386584"/>
-            <a:ext cx="320040" cy="713232"/>
+            <a:off x="629107" y="3538727"/>
+            <a:ext cx="320040" cy="658368"/>
           </a:xfrm>
           <a:prstGeom prst="rect">
             <a:avLst/>
@@ -13030,21 +13060,21 @@
                   <a:srgbClr val="009881"/>
                 </a:solidFill>
               </a:rPr>
-              <a:t>2.</a:t>
-            </a:r>
-          </a:p>
-        </p:txBody>
-      </p:sp>
-      <p:sp>
-        <p:nvSpPr>
-          <p:cNvPr id="8" name="TextBox 7"/>
+              <a:t>3.</a:t>
+            </a:r>
+          </a:p>
+        </p:txBody>
+      </p:sp>
+      <p:sp>
+        <p:nvSpPr>
+          <p:cNvPr id="13" name="TextBox 12"/>
           <p:cNvSpPr txBox="1"/>
           <p:nvPr/>
         </p:nvSpPr>
         <p:spPr>
           <a:xfrm>
-            <a:off x="822960" y="2386584"/>
-            <a:ext cx="7360920" cy="713232"/>
+            <a:off x="949147" y="3538727"/>
+            <a:ext cx="7459675" cy="658368"/>
           </a:xfrm>
           <a:prstGeom prst="rect">
             <a:avLst/>
@@ -13067,21 +13097,21 @@
                   <a:srgbClr val="4A4A49"/>
                 </a:solidFill>
               </a:rPr>
-              <a:t>Jaký je rozdíl mezi procesními, produktovými a zdrojovými metrikami ve Vašem návrhu? Uveďte konkrétní příklad metriky z každé skupiny a vysvětlete, proč je důležitá, jakou má oporu ve zdrojích a jak je v práci prakticky měřená.</a:t>
-            </a:r>
-          </a:p>
-        </p:txBody>
-      </p:sp>
-      <p:sp>
-        <p:nvSpPr>
-          <p:cNvPr id="9" name="TextBox 8"/>
+              <a:t>Jak jste rozlišoval mezi vlastním autorským přínosem a výstupy AI asistenta při tvorbě textu, diagnostiky experimentu a měřicí infrastruktury?</a:t>
+            </a:r>
+          </a:p>
+        </p:txBody>
+      </p:sp>
+      <p:sp>
+        <p:nvSpPr>
+          <p:cNvPr id="14" name="TextBox 13"/>
           <p:cNvSpPr txBox="1"/>
           <p:nvPr/>
         </p:nvSpPr>
         <p:spPr>
           <a:xfrm>
-            <a:off x="502920" y="3099816"/>
-            <a:ext cx="320040" cy="713232"/>
+            <a:off x="629107" y="4197095"/>
+            <a:ext cx="320040" cy="658368"/>
           </a:xfrm>
           <a:prstGeom prst="rect">
             <a:avLst/>
@@ -13104,21 +13134,21 @@
                   <a:srgbClr val="009881"/>
                 </a:solidFill>
               </a:rPr>
-              <a:t>3.</a:t>
-            </a:r>
-          </a:p>
-        </p:txBody>
-      </p:sp>
-      <p:sp>
-        <p:nvSpPr>
-          <p:cNvPr id="10" name="TextBox 9"/>
+              <a:t>4.</a:t>
+            </a:r>
+          </a:p>
+        </p:txBody>
+      </p:sp>
+      <p:sp>
+        <p:nvSpPr>
+          <p:cNvPr id="15" name="TextBox 14"/>
           <p:cNvSpPr txBox="1"/>
           <p:nvPr/>
         </p:nvSpPr>
         <p:spPr>
           <a:xfrm>
-            <a:off x="822960" y="3099816"/>
-            <a:ext cx="7360920" cy="713232"/>
+            <a:off x="949147" y="4197095"/>
+            <a:ext cx="7459675" cy="658368"/>
           </a:xfrm>
           <a:prstGeom prst="rect">
             <a:avLst/>
@@ -13141,21 +13171,21 @@
                   <a:srgbClr val="4A4A49"/>
                 </a:solidFill>
               </a:rPr>
-              <a:t>Jak jste rozlišoval mezi vlastním autorským přínosem a výstupy AI asistenta při tvorbě textu, diagnostiky experimentu a měřicí infrastruktury?</a:t>
-            </a:r>
-          </a:p>
-        </p:txBody>
-      </p:sp>
-      <p:sp>
-        <p:nvSpPr>
-          <p:cNvPr id="11" name="TextBox 10"/>
+              <a:t>V práci zmiňujete posun od obecného pravidla ke konkrétnímu příkazu a následně k verifikačnímu kroku. Uveďte konkrétní příklad z Vaší případové studie a vysvětlete, proč právě verifikační krok zlepšil chování agenta.</a:t>
+            </a:r>
+          </a:p>
+        </p:txBody>
+      </p:sp>
+      <p:sp>
+        <p:nvSpPr>
+          <p:cNvPr id="16" name="TextBox 15"/>
           <p:cNvSpPr txBox="1"/>
           <p:nvPr/>
         </p:nvSpPr>
         <p:spPr>
           <a:xfrm>
-            <a:off x="502920" y="3813048"/>
-            <a:ext cx="320040" cy="713232"/>
+            <a:off x="629107" y="4983479"/>
+            <a:ext cx="7779715" cy="292608"/>
           </a:xfrm>
           <a:prstGeom prst="rect">
             <a:avLst/>
@@ -13173,26 +13203,26 @@
           <a:p>
             <a:pPr algn="l"/>
             <a:r>
-              <a:rPr sz="1200" b="1" i="0">
+              <a:rPr sz="1400" b="1" i="0">
                 <a:solidFill>
                   <a:srgbClr val="009881"/>
                 </a:solidFill>
               </a:rPr>
-              <a:t>4.</a:t>
-            </a:r>
-          </a:p>
-        </p:txBody>
-      </p:sp>
-      <p:sp>
-        <p:nvSpPr>
-          <p:cNvPr id="12" name="TextBox 11"/>
+              <a:t>Oponent — Ing. Richard Antonín Novák, Ph.D.    ·    1 otázka</a:t>
+            </a:r>
+          </a:p>
+        </p:txBody>
+      </p:sp>
+      <p:sp>
+        <p:nvSpPr>
+          <p:cNvPr id="17" name="TextBox 16"/>
           <p:cNvSpPr txBox="1"/>
           <p:nvPr/>
         </p:nvSpPr>
         <p:spPr>
           <a:xfrm>
-            <a:off x="822960" y="3813048"/>
-            <a:ext cx="7360920" cy="713232"/>
+            <a:off x="629107" y="5330951"/>
+            <a:ext cx="320040" cy="868680"/>
           </a:xfrm>
           <a:prstGeom prst="rect">
             <a:avLst/>
@@ -13210,100 +13240,26 @@
           <a:p>
             <a:pPr algn="l"/>
             <a:r>
-              <a:rPr sz="1100" b="0" i="0">
-                <a:solidFill>
-                  <a:srgbClr val="4A4A49"/>
+              <a:rPr sz="1200" b="1" i="0">
+                <a:solidFill>
+                  <a:srgbClr val="009881"/>
                 </a:solidFill>
               </a:rPr>
-              <a:t>V práci zmiňujete posun od obecného pravidla ke konkrétnímu příkazu a následně k verifikačnímu kroku. Uveďte konkrétní příklad z Vaší případové studie a vysvětlete, proč právě verifikační krok zlepšil chování agenta.</a:t>
-            </a:r>
-          </a:p>
-        </p:txBody>
-      </p:sp>
-      <p:sp>
-        <p:nvSpPr>
-          <p:cNvPr id="13" name="TextBox 12"/>
+              <a:t>1.</a:t>
+            </a:r>
+          </a:p>
+        </p:txBody>
+      </p:sp>
+      <p:sp>
+        <p:nvSpPr>
+          <p:cNvPr id="18" name="TextBox 17"/>
           <p:cNvSpPr txBox="1"/>
           <p:nvPr/>
         </p:nvSpPr>
         <p:spPr>
           <a:xfrm>
-            <a:off x="502920" y="4690872"/>
-            <a:ext cx="7680960" cy="292608"/>
-          </a:xfrm>
-          <a:prstGeom prst="rect">
-            <a:avLst/>
-          </a:prstGeom>
-          <a:noFill/>
-          <a:ln>
-            <a:noFill/>
-          </a:ln>
-        </p:spPr>
-        <p:txBody>
-          <a:bodyPr wrap="square" lIns="73152" rIns="73152" tIns="36576" bIns="36576">
-            <a:spAutoFit/>
-          </a:bodyPr>
-          <a:lstStyle/>
-          <a:p>
-            <a:pPr algn="l"/>
-            <a:r>
-              <a:rPr sz="1400" b="1" i="0">
-                <a:solidFill>
-                  <a:srgbClr val="009881"/>
-                </a:solidFill>
-              </a:rPr>
-              <a:t>Oponent — Ing. Richard Antonín Novák, Ph.D.    ·    1 otázka</a:t>
-            </a:r>
-          </a:p>
-        </p:txBody>
-      </p:sp>
-      <p:sp>
-        <p:nvSpPr>
-          <p:cNvPr id="14" name="TextBox 13"/>
-          <p:cNvSpPr txBox="1"/>
-          <p:nvPr/>
-        </p:nvSpPr>
-        <p:spPr>
-          <a:xfrm>
-            <a:off x="502920" y="5038344"/>
-            <a:ext cx="320040" cy="1005840"/>
-          </a:xfrm>
-          <a:prstGeom prst="rect">
-            <a:avLst/>
-          </a:prstGeom>
-          <a:noFill/>
-          <a:ln>
-            <a:noFill/>
-          </a:ln>
-        </p:spPr>
-        <p:txBody>
-          <a:bodyPr wrap="square" lIns="73152" rIns="73152" tIns="36576" bIns="36576">
-            <a:spAutoFit/>
-          </a:bodyPr>
-          <a:lstStyle/>
-          <a:p>
-            <a:pPr algn="l"/>
-            <a:r>
-              <a:rPr sz="1200" b="1" i="0">
-                <a:solidFill>
-                  <a:srgbClr val="009881"/>
-                </a:solidFill>
-              </a:rPr>
-              <a:t>1.</a:t>
-            </a:r>
-          </a:p>
-        </p:txBody>
-      </p:sp>
-      <p:sp>
-        <p:nvSpPr>
-          <p:cNvPr id="15" name="TextBox 14"/>
-          <p:cNvSpPr txBox="1"/>
-          <p:nvPr/>
-        </p:nvSpPr>
-        <p:spPr>
-          <a:xfrm>
-            <a:off x="822960" y="5038344"/>
-            <a:ext cx="7360920" cy="1005840"/>
+            <a:off x="949147" y="5330951"/>
+            <a:ext cx="7459675" cy="868680"/>
           </a:xfrm>
           <a:prstGeom prst="rect">
             <a:avLst/>

</xml_diff>

<commit_message>
chore(presentation): slide 9 - zvětšit font otázek (11->13 pt), přegenerovat pdf/png
Text otázek vedoucího i oponenta zvětšen z 11 na 13 pt kvůli čitelnosti,
rozteče řádků a sekcí upraveny tak, aby se vše vešlo nad číslo stránky.
Přegenerován trackovaný obhajoba-draft-v1.pdf a slides/slide-09.png.

Co-Authored-By: Claude Opus 4.8 <noreply@anthropic.com>
</commit_message>
<xml_diff>
--- a/presentation/work/obhajoba-draft-v1.pptx
+++ b/presentation/work/obhajoba-draft-v1.pptx
@@ -12851,7 +12851,7 @@
         </p:nvSpPr>
         <p:spPr>
           <a:xfrm>
-            <a:off x="629107" y="1874519"/>
+            <a:off x="629107" y="1828800"/>
             <a:ext cx="7779715" cy="292608"/>
           </a:xfrm>
           <a:prstGeom prst="rect">
@@ -12888,8 +12888,8 @@
         </p:nvSpPr>
         <p:spPr>
           <a:xfrm>
-            <a:off x="629107" y="2221991"/>
-            <a:ext cx="320040" cy="658368"/>
+            <a:off x="629107" y="2157984"/>
+            <a:ext cx="320040" cy="731520"/>
           </a:xfrm>
           <a:prstGeom prst="rect">
             <a:avLst/>
@@ -12907,7 +12907,7 @@
           <a:p>
             <a:pPr algn="l"/>
             <a:r>
-              <a:rPr sz="1200" b="1" i="0">
+              <a:rPr sz="1300" b="1" i="0">
                 <a:solidFill>
                   <a:srgbClr val="009881"/>
                 </a:solidFill>
@@ -12925,8 +12925,8 @@
         </p:nvSpPr>
         <p:spPr>
           <a:xfrm>
-            <a:off x="949147" y="2221991"/>
-            <a:ext cx="7459675" cy="658368"/>
+            <a:off x="949147" y="2157984"/>
+            <a:ext cx="7459675" cy="731520"/>
           </a:xfrm>
           <a:prstGeom prst="rect">
             <a:avLst/>
@@ -12944,7 +12944,7 @@
           <a:p>
             <a:pPr algn="l"/>
             <a:r>
-              <a:rPr sz="1100" b="0" i="0">
+              <a:rPr sz="1300" b="0" i="0">
                 <a:solidFill>
                   <a:srgbClr val="4A4A49"/>
                 </a:solidFill>
@@ -12962,8 +12962,8 @@
         </p:nvSpPr>
         <p:spPr>
           <a:xfrm>
-            <a:off x="629107" y="2880359"/>
-            <a:ext cx="320040" cy="658368"/>
+            <a:off x="629107" y="2889504"/>
+            <a:ext cx="320040" cy="731520"/>
           </a:xfrm>
           <a:prstGeom prst="rect">
             <a:avLst/>
@@ -12981,7 +12981,7 @@
           <a:p>
             <a:pPr algn="l"/>
             <a:r>
-              <a:rPr sz="1200" b="1" i="0">
+              <a:rPr sz="1300" b="1" i="0">
                 <a:solidFill>
                   <a:srgbClr val="009881"/>
                 </a:solidFill>
@@ -12999,8 +12999,8 @@
         </p:nvSpPr>
         <p:spPr>
           <a:xfrm>
-            <a:off x="949147" y="2880359"/>
-            <a:ext cx="7459675" cy="658368"/>
+            <a:off x="949147" y="2889504"/>
+            <a:ext cx="7459675" cy="731520"/>
           </a:xfrm>
           <a:prstGeom prst="rect">
             <a:avLst/>
@@ -13018,7 +13018,7 @@
           <a:p>
             <a:pPr algn="l"/>
             <a:r>
-              <a:rPr sz="1100" b="0" i="0">
+              <a:rPr sz="1300" b="0" i="0">
                 <a:solidFill>
                   <a:srgbClr val="4A4A49"/>
                 </a:solidFill>
@@ -13036,8 +13036,8 @@
         </p:nvSpPr>
         <p:spPr>
           <a:xfrm>
-            <a:off x="629107" y="3538727"/>
-            <a:ext cx="320040" cy="658368"/>
+            <a:off x="629107" y="3621024"/>
+            <a:ext cx="320040" cy="731520"/>
           </a:xfrm>
           <a:prstGeom prst="rect">
             <a:avLst/>
@@ -13055,7 +13055,7 @@
           <a:p>
             <a:pPr algn="l"/>
             <a:r>
-              <a:rPr sz="1200" b="1" i="0">
+              <a:rPr sz="1300" b="1" i="0">
                 <a:solidFill>
                   <a:srgbClr val="009881"/>
                 </a:solidFill>
@@ -13073,8 +13073,8 @@
         </p:nvSpPr>
         <p:spPr>
           <a:xfrm>
-            <a:off x="949147" y="3538727"/>
-            <a:ext cx="7459675" cy="658368"/>
+            <a:off x="949147" y="3621024"/>
+            <a:ext cx="7459675" cy="731520"/>
           </a:xfrm>
           <a:prstGeom prst="rect">
             <a:avLst/>
@@ -13092,7 +13092,7 @@
           <a:p>
             <a:pPr algn="l"/>
             <a:r>
-              <a:rPr sz="1100" b="0" i="0">
+              <a:rPr sz="1300" b="0" i="0">
                 <a:solidFill>
                   <a:srgbClr val="4A4A49"/>
                 </a:solidFill>
@@ -13110,8 +13110,8 @@
         </p:nvSpPr>
         <p:spPr>
           <a:xfrm>
-            <a:off x="629107" y="4197095"/>
-            <a:ext cx="320040" cy="658368"/>
+            <a:off x="629107" y="4352544"/>
+            <a:ext cx="320040" cy="731520"/>
           </a:xfrm>
           <a:prstGeom prst="rect">
             <a:avLst/>
@@ -13129,7 +13129,7 @@
           <a:p>
             <a:pPr algn="l"/>
             <a:r>
-              <a:rPr sz="1200" b="1" i="0">
+              <a:rPr sz="1300" b="1" i="0">
                 <a:solidFill>
                   <a:srgbClr val="009881"/>
                 </a:solidFill>
@@ -13147,8 +13147,8 @@
         </p:nvSpPr>
         <p:spPr>
           <a:xfrm>
-            <a:off x="949147" y="4197095"/>
-            <a:ext cx="7459675" cy="658368"/>
+            <a:off x="949147" y="4352544"/>
+            <a:ext cx="7459675" cy="731520"/>
           </a:xfrm>
           <a:prstGeom prst="rect">
             <a:avLst/>
@@ -13166,7 +13166,7 @@
           <a:p>
             <a:pPr algn="l"/>
             <a:r>
-              <a:rPr sz="1100" b="0" i="0">
+              <a:rPr sz="1300" b="0" i="0">
                 <a:solidFill>
                   <a:srgbClr val="4A4A49"/>
                 </a:solidFill>
@@ -13184,7 +13184,7 @@
         </p:nvSpPr>
         <p:spPr>
           <a:xfrm>
-            <a:off x="629107" y="4983479"/>
+            <a:off x="629107" y="5175504"/>
             <a:ext cx="7779715" cy="292608"/>
           </a:xfrm>
           <a:prstGeom prst="rect">
@@ -13221,8 +13221,8 @@
         </p:nvSpPr>
         <p:spPr>
           <a:xfrm>
-            <a:off x="629107" y="5330951"/>
-            <a:ext cx="320040" cy="868680"/>
+            <a:off x="629107" y="5504688"/>
+            <a:ext cx="320040" cy="777240"/>
           </a:xfrm>
           <a:prstGeom prst="rect">
             <a:avLst/>
@@ -13240,7 +13240,7 @@
           <a:p>
             <a:pPr algn="l"/>
             <a:r>
-              <a:rPr sz="1200" b="1" i="0">
+              <a:rPr sz="1300" b="1" i="0">
                 <a:solidFill>
                   <a:srgbClr val="009881"/>
                 </a:solidFill>
@@ -13258,8 +13258,8 @@
         </p:nvSpPr>
         <p:spPr>
           <a:xfrm>
-            <a:off x="949147" y="5330951"/>
-            <a:ext cx="7459675" cy="868680"/>
+            <a:off x="949147" y="5504688"/>
+            <a:ext cx="7459675" cy="777240"/>
           </a:xfrm>
           <a:prstGeom prst="rect">
             <a:avLst/>
@@ -13277,7 +13277,7 @@
           <a:p>
             <a:pPr algn="l"/>
             <a:r>
-              <a:rPr sz="1100" b="0" i="0">
+              <a:rPr sz="1300" b="0" i="0">
                 <a:solidFill>
                   <a:srgbClr val="4A4A49"/>
                 </a:solidFill>

</xml_diff>